<commit_message>
Page Number added in slides!
</commit_message>
<xml_diff>
--- a/Project Overview.pptx
+++ b/Project Overview.pptx
@@ -1144,7 +1144,7 @@
   <p:sldLayoutIdLst>
     <p:sldLayoutId id="2147483649" r:id="rId1"/>
   </p:sldLayoutIdLst>
-  <p:hf sldNum="0" hdr="0" ftr="0" dt="0"/>
+  <p:hf hdr="0" ftr="0" dt="0"/>
   <p:txStyles>
     <p:titleStyle>
       <a:lvl1pPr algn="ctr" defTabSz="914400" rtl="0" eaLnBrk="1" latinLnBrk="0" hangingPunct="1">
@@ -2131,45 +2131,6 @@
           </a:p>
         </p:txBody>
       </p:sp>
-      <p:sp>
-        <p:nvSpPr>
-          <p:cNvPr id="9" name="Text 7"/>
-          <p:cNvSpPr/>
-          <p:nvPr/>
-        </p:nvSpPr>
-        <p:spPr>
-          <a:xfrm>
-            <a:off x="11475720" y="6473952"/>
-            <a:ext cx="548640" cy="274320"/>
-          </a:xfrm>
-          <a:prstGeom prst="rect">
-            <a:avLst/>
-          </a:prstGeom>
-          <a:noFill/>
-          <a:ln/>
-        </p:spPr>
-        <p:txBody>
-          <a:bodyPr wrap="square" lIns="0" tIns="0" rIns="0" bIns="0" rtlCol="0" anchor="ctr"/>
-          <a:lstStyle/>
-          <a:p>
-            <a:pPr marL="0" indent="0" algn="r">
-              <a:buNone/>
-            </a:pPr>
-            <a:r>
-              <a:rPr lang="en-US" sz="1000" dirty="0">
-                <a:solidFill>
-                  <a:srgbClr val="5A5F6B"/>
-                </a:solidFill>
-                <a:latin typeface="Calibri" pitchFamily="34" charset="0"/>
-                <a:ea typeface="Calibri" pitchFamily="34" charset="-122"/>
-                <a:cs typeface="Calibri" pitchFamily="34" charset="-120"/>
-              </a:rPr>
-              <a:t>14</a:t>
-            </a:r>
-            <a:endParaRPr lang="en-US" sz="1000" dirty="0"/>
-          </a:p>
-        </p:txBody>
-      </p:sp>
     </p:spTree>
   </p:cSld>
   <p:clrMapOvr>
@@ -3524,7 +3485,7 @@
               <a:buNone/>
             </a:pPr>
             <a:r>
-              <a:rPr lang="en-US" sz="1000" dirty="0">
+              <a:rPr lang="en-US" sz="2000" dirty="0">
                 <a:solidFill>
                   <a:srgbClr val="8A8F99"/>
                 </a:solidFill>
@@ -3532,9 +3493,8 @@
                 <a:ea typeface="Calibri" pitchFamily="34" charset="-122"/>
                 <a:cs typeface="Calibri" pitchFamily="34" charset="-120"/>
               </a:rPr>
-              <a:t>04</a:t>
-            </a:r>
-            <a:endParaRPr lang="en-US" sz="1000" dirty="0"/>
+              <a:t>01</a:t>
+            </a:r>
           </a:p>
         </p:txBody>
       </p:sp>
@@ -4616,7 +4576,7 @@
               <a:buNone/>
             </a:pPr>
             <a:r>
-              <a:rPr lang="en-US" sz="1000" dirty="0">
+              <a:rPr lang="en-US" sz="2000" dirty="0">
                 <a:solidFill>
                   <a:srgbClr val="8A8F99"/>
                 </a:solidFill>
@@ -4624,9 +4584,8 @@
                 <a:ea typeface="Calibri" pitchFamily="34" charset="-122"/>
                 <a:cs typeface="Calibri" pitchFamily="34" charset="-120"/>
               </a:rPr>
-              <a:t>05</a:t>
-            </a:r>
-            <a:endParaRPr lang="en-US" sz="1000" dirty="0"/>
+              <a:t>03</a:t>
+            </a:r>
           </a:p>
         </p:txBody>
       </p:sp>
@@ -5453,7 +5412,7 @@
               <a:buNone/>
             </a:pPr>
             <a:r>
-              <a:rPr lang="en-US" sz="1000" dirty="0">
+              <a:rPr lang="en-US" sz="2000" dirty="0">
                 <a:solidFill>
                   <a:srgbClr val="8A8F99"/>
                 </a:solidFill>
@@ -5461,9 +5420,9 @@
                 <a:ea typeface="Calibri" pitchFamily="34" charset="-122"/>
                 <a:cs typeface="Calibri" pitchFamily="34" charset="-120"/>
               </a:rPr>
-              <a:t>06</a:t>
-            </a:r>
-            <a:endParaRPr lang="en-US" sz="1000" dirty="0"/>
+              <a:t>04</a:t>
+            </a:r>
+            <a:endParaRPr lang="en-US" sz="2000" dirty="0"/>
           </a:p>
         </p:txBody>
       </p:sp>
@@ -6381,7 +6340,7 @@
               <a:buNone/>
             </a:pPr>
             <a:r>
-              <a:rPr lang="en-US" sz="1000" dirty="0">
+              <a:rPr lang="en-US" sz="2000" dirty="0">
                 <a:solidFill>
                   <a:srgbClr val="8A8F99"/>
                 </a:solidFill>
@@ -6389,9 +6348,9 @@
                 <a:ea typeface="Calibri" pitchFamily="34" charset="-122"/>
                 <a:cs typeface="Calibri" pitchFamily="34" charset="-120"/>
               </a:rPr>
-              <a:t>07</a:t>
-            </a:r>
-            <a:endParaRPr lang="en-US" sz="1000" dirty="0"/>
+              <a:t>05</a:t>
+            </a:r>
+            <a:endParaRPr lang="en-US" sz="2000" dirty="0"/>
           </a:p>
         </p:txBody>
       </p:sp>
@@ -8429,7 +8388,7 @@
               <a:buNone/>
             </a:pPr>
             <a:r>
-              <a:rPr lang="en-US" sz="1000" dirty="0">
+              <a:rPr lang="en-US" sz="2000" dirty="0">
                 <a:solidFill>
                   <a:srgbClr val="8A8F99"/>
                 </a:solidFill>
@@ -8437,9 +8396,9 @@
                 <a:ea typeface="Calibri" pitchFamily="34" charset="-122"/>
                 <a:cs typeface="Calibri" pitchFamily="34" charset="-120"/>
               </a:rPr>
-              <a:t>08</a:t>
-            </a:r>
-            <a:endParaRPr lang="en-US" sz="1000" dirty="0"/>
+              <a:t>06</a:t>
+            </a:r>
+            <a:endParaRPr lang="en-US" sz="2000" dirty="0"/>
           </a:p>
         </p:txBody>
       </p:sp>
@@ -9586,17 +9545,16 @@
               <a:buNone/>
             </a:pPr>
             <a:r>
-              <a:rPr lang="en-US" sz="1000" dirty="0">
+              <a:rPr lang="en-US" sz="2000" dirty="0">
                 <a:solidFill>
                   <a:srgbClr val="8A8F99"/>
                 </a:solidFill>
                 <a:latin typeface="Calibri" pitchFamily="34" charset="0"/>
-                <a:ea typeface="Calibri" pitchFamily="34" charset="-122"/>
                 <a:cs typeface="Calibri" pitchFamily="34" charset="-120"/>
               </a:rPr>
-              <a:t>10</a:t>
-            </a:r>
-            <a:endParaRPr lang="en-US" sz="1000" dirty="0"/>
+              <a:t>07</a:t>
+            </a:r>
+            <a:endParaRPr lang="en-US" sz="2000" dirty="0"/>
           </a:p>
         </p:txBody>
       </p:sp>
@@ -10303,17 +10261,16 @@
               <a:buNone/>
             </a:pPr>
             <a:r>
-              <a:rPr lang="en-US" sz="1000" dirty="0">
+              <a:rPr lang="en-US" sz="2000" dirty="0">
                 <a:solidFill>
                   <a:srgbClr val="8A8F99"/>
                 </a:solidFill>
                 <a:latin typeface="Calibri" pitchFamily="34" charset="0"/>
-                <a:ea typeface="Calibri" pitchFamily="34" charset="-122"/>
                 <a:cs typeface="Calibri" pitchFamily="34" charset="-120"/>
               </a:rPr>
-              <a:t>11</a:t>
-            </a:r>
-            <a:endParaRPr lang="en-US" sz="1000" dirty="0"/>
+              <a:t>08</a:t>
+            </a:r>
+            <a:endParaRPr lang="en-US" sz="2000" dirty="0"/>
           </a:p>
         </p:txBody>
       </p:sp>
@@ -10989,17 +10946,20 @@
               <a:buNone/>
             </a:pPr>
             <a:r>
-              <a:rPr lang="en-US" sz="1000" dirty="0">
-                <a:solidFill>
-                  <a:srgbClr val="5A5F6B"/>
+              <a:rPr lang="en-US" sz="2000" dirty="0">
+                <a:solidFill>
+                  <a:schemeClr val="bg1"/>
                 </a:solidFill>
                 <a:latin typeface="Calibri" pitchFamily="34" charset="0"/>
-                <a:ea typeface="Calibri" pitchFamily="34" charset="-122"/>
                 <a:cs typeface="Calibri" pitchFamily="34" charset="-120"/>
               </a:rPr>
-              <a:t>12</a:t>
-            </a:r>
-            <a:endParaRPr lang="en-US" sz="1000" dirty="0"/>
+              <a:t>09</a:t>
+            </a:r>
+            <a:endParaRPr lang="en-US" sz="2000" dirty="0">
+              <a:solidFill>
+                <a:schemeClr val="bg1"/>
+              </a:solidFill>
+            </a:endParaRPr>
           </a:p>
         </p:txBody>
       </p:sp>

</xml_diff>